<commit_message>
Name the program and term without a graduation year
File headers, the title-screen credit, a changelog signature and the
June class deck's byline and footer now say Lipscomb University and the
Summer 2026 term. Also drops the "honest" asides from two docs, rewords
the submission note so it does not read as hand-coding, fixes two stale
plurals, and marks the archived class post as a record.

Co-Authored-By: Claude Fable 5.1 <noreply@anthropic.com>
Claude-Session: https://claude.ai/code/session_0187QpzSj3Q4KUbxmFcYfboj
</commit_message>
<xml_diff>
--- a/submission-media/ENGR5513-FinalBoss-Presentation.pptx
+++ b/submission-media/ENGR5513-FinalBoss-Presentation.pptx
@@ -1877,6 +1877,10 @@
             <a:prstDash val="lgDash"/>
           </a:ln>
         </p:spPr>
+        <p:txBody>
+          <a:bodyPr/>
+          <a:p/>
+        </p:txBody>
       </p:sp>
       <p:sp>
         <p:nvSpPr>
@@ -1911,7 +1915,7 @@
                 <a:ea typeface="Calibri" pitchFamily="34" charset="-122"/>
                 <a:cs typeface="Calibri" pitchFamily="34" charset="-120"/>
               </a:rPr>
-              <a:t>Forrest Wright — Lipscomb MSAI ’26      ENGR 5513, Summer 2026 — Dr. Steve Nordstrom</a:t>
+              <a:t>Forrest Wright — Lipscomb University      ENGR 5513, Summer 2026 — Dr. Steve Nordstrom</a:t>
             </a:r>
             <a:endParaRPr lang="en-US" sz="1150" dirty="0"/>
           </a:p>
@@ -1919,7 +1923,7 @@
       </p:sp>
       <p:pic>
         <p:nvPicPr>
-          <p:cNvPr id="8" name="Image 0" descr="C:/Users/User/CoworkProjects/_wrt-shots/deck-out/title-screen-prod.png">    </p:cNvPr>
+          <p:cNvPr id="8" name="Image 0" descr="">    </p:cNvPr>
           <p:cNvPicPr>
             <a:picLocks noChangeAspect="1"/>
           </p:cNvPicPr>
@@ -1969,6 +1973,10 @@
             <a:prstDash val="solid"/>
           </a:ln>
         </p:spPr>
+        <p:txBody>
+          <a:bodyPr/>
+          <a:p/>
+        </p:txBody>
       </p:sp>
       <p:sp>
         <p:nvSpPr>
@@ -2465,7 +2473,7 @@
       </p:sp>
       <p:pic>
         <p:nvPicPr>
-          <p:cNvPr id="8" name="Image 0" descr="C:/Users/User/CoworkProjects/weekend-road-trip/submission-media/weekend-road-trip-ghost-race.png">    </p:cNvPr>
+          <p:cNvPr id="8" name="Image 0" descr="">    </p:cNvPr>
           <p:cNvPicPr>
             <a:picLocks noChangeAspect="1"/>
           </p:cNvPicPr>
@@ -2515,6 +2523,10 @@
             <a:prstDash val="solid"/>
           </a:ln>
         </p:spPr>
+        <p:txBody>
+          <a:bodyPr/>
+          <a:p/>
+        </p:txBody>
       </p:sp>
       <p:sp>
         <p:nvSpPr>
@@ -2633,6 +2645,10 @@
             <a:prstDash val="lgDash"/>
           </a:ln>
         </p:spPr>
+        <p:txBody>
+          <a:bodyPr/>
+          <a:p/>
+        </p:txBody>
       </p:sp>
       <p:sp>
         <p:nvSpPr>
@@ -2667,7 +2683,7 @@
                 <a:ea typeface="Calibri" pitchFamily="34" charset="-122"/>
                 <a:cs typeface="Calibri" pitchFamily="34" charset="-120"/>
               </a:rPr>
-              <a:t>Forrest Wright · ENGR 5513 Applied AI in Engineering · Lipscomb MSAI · Summer 2026</a:t>
+              <a:t>Forrest Wright · ENGR 5513 Applied AI in Engineering · Lipscomb University · Summer 2026</a:t>
             </a:r>
             <a:endParaRPr lang="en-US" sz="1000" dirty="0"/>
           </a:p>
@@ -2785,7 +2801,7 @@
       </p:sp>
       <p:pic>
         <p:nvPicPr>
-          <p:cNvPr id="4" name="Image 0" descr="C:/Users/User/CoworkProjects/weekend-road-trip/submission-media/hero-lanes.png">    </p:cNvPr>
+          <p:cNvPr id="4" name="Image 0" descr="">    </p:cNvPr>
           <p:cNvPicPr>
             <a:picLocks noChangeAspect="1"/>
           </p:cNvPicPr>
@@ -2835,6 +2851,10 @@
             <a:prstDash val="solid"/>
           </a:ln>
         </p:spPr>
+        <p:txBody>
+          <a:bodyPr/>
+          <a:p/>
+        </p:txBody>
       </p:sp>
       <p:sp>
         <p:nvSpPr>
@@ -2901,6 +2921,10 @@
             <a:prstDash val="solid"/>
           </a:ln>
         </p:spPr>
+        <p:txBody>
+          <a:bodyPr/>
+          <a:p/>
+        </p:txBody>
       </p:sp>
       <p:sp>
         <p:nvSpPr>
@@ -3006,6 +3030,10 @@
             <a:prstDash val="solid"/>
           </a:ln>
         </p:spPr>
+        <p:txBody>
+          <a:bodyPr/>
+          <a:p/>
+        </p:txBody>
       </p:sp>
       <p:sp>
         <p:nvSpPr>
@@ -3111,6 +3139,10 @@
             <a:prstDash val="solid"/>
           </a:ln>
         </p:spPr>
+        <p:txBody>
+          <a:bodyPr/>
+          <a:p/>
+        </p:txBody>
       </p:sp>
       <p:sp>
         <p:nvSpPr>
@@ -5864,7 +5896,7 @@
       </p:sp>
       <p:pic>
         <p:nvPicPr>
-          <p:cNvPr id="12" name="Image 0" descr="C:/Users/User/CoworkProjects/_wrt-shots/deck-out/vercel-deployments-strip.png">    </p:cNvPr>
+          <p:cNvPr id="12" name="Image 0" descr="">    </p:cNvPr>
           <p:cNvPicPr>
             <a:picLocks noChangeAspect="1"/>
           </p:cNvPicPr>
@@ -5914,6 +5946,10 @@
             <a:prstDash val="solid"/>
           </a:ln>
         </p:spPr>
+        <p:txBody>
+          <a:bodyPr/>
+          <a:p/>
+        </p:txBody>
       </p:sp>
       <p:sp>
         <p:nvSpPr>
@@ -5956,7 +5992,7 @@
       </p:sp>
       <p:pic>
         <p:nvPicPr>
-          <p:cNvPr id="15" name="Image 1" descr="C:/Users/User/CoworkProjects/final-boss-submission/screenshots/06-preview-deployment-colorway-cropped.png">    </p:cNvPr>
+          <p:cNvPr id="15" name="Image 1" descr="">    </p:cNvPr>
           <p:cNvPicPr>
             <a:picLocks noChangeAspect="1"/>
           </p:cNvPicPr>
@@ -6006,6 +6042,10 @@
             <a:prstDash val="solid"/>
           </a:ln>
         </p:spPr>
+        <p:txBody>
+          <a:bodyPr/>
+          <a:p/>
+        </p:txBody>
       </p:sp>
       <p:sp>
         <p:nvSpPr>
@@ -6260,6 +6300,10 @@
             <a:prstDash val="solid"/>
           </a:ln>
         </p:spPr>
+        <p:txBody>
+          <a:bodyPr/>
+          <a:p/>
+        </p:txBody>
       </p:sp>
       <p:sp>
         <p:nvSpPr>
@@ -6340,6 +6384,10 @@
             <a:tailEnd type="triangle"/>
           </a:ln>
         </p:spPr>
+        <p:txBody>
+          <a:bodyPr/>
+          <a:p/>
+        </p:txBody>
       </p:sp>
       <p:sp>
         <p:nvSpPr>
@@ -6364,6 +6412,10 @@
             <a:tailEnd type="triangle"/>
           </a:ln>
         </p:spPr>
+        <p:txBody>
+          <a:bodyPr/>
+          <a:p/>
+        </p:txBody>
       </p:sp>
       <p:sp>
         <p:nvSpPr>
@@ -6388,6 +6440,10 @@
             <a:tailEnd type="triangle"/>
           </a:ln>
         </p:spPr>
+        <p:txBody>
+          <a:bodyPr/>
+          <a:p/>
+        </p:txBody>
       </p:sp>
       <p:sp>
         <p:nvSpPr>
@@ -6415,6 +6471,10 @@
             <a:prstDash val="solid"/>
           </a:ln>
         </p:spPr>
+        <p:txBody>
+          <a:bodyPr/>
+          <a:p/>
+        </p:txBody>
       </p:sp>
       <p:sp>
         <p:nvSpPr>
@@ -6576,6 +6636,10 @@
             <a:prstDash val="solid"/>
           </a:ln>
         </p:spPr>
+        <p:txBody>
+          <a:bodyPr/>
+          <a:p/>
+        </p:txBody>
       </p:sp>
       <p:sp>
         <p:nvSpPr>
@@ -6737,6 +6801,10 @@
             <a:prstDash val="solid"/>
           </a:ln>
         </p:spPr>
+        <p:txBody>
+          <a:bodyPr/>
+          <a:p/>
+        </p:txBody>
       </p:sp>
       <p:sp>
         <p:nvSpPr>
@@ -7086,6 +7154,10 @@
             <a:prstDash val="solid"/>
           </a:ln>
         </p:spPr>
+        <p:txBody>
+          <a:bodyPr/>
+          <a:p/>
+        </p:txBody>
       </p:sp>
       <p:sp>
         <p:nvSpPr>
@@ -7166,6 +7238,10 @@
             <a:tailEnd type="triangle"/>
           </a:ln>
         </p:spPr>
+        <p:txBody>
+          <a:bodyPr/>
+          <a:p/>
+        </p:txBody>
       </p:sp>
       <p:sp>
         <p:nvSpPr>
@@ -7193,6 +7269,10 @@
             <a:prstDash val="solid"/>
           </a:ln>
         </p:spPr>
+        <p:txBody>
+          <a:bodyPr/>
+          <a:p/>
+        </p:txBody>
       </p:sp>
       <p:sp>
         <p:nvSpPr>
@@ -7273,6 +7353,10 @@
             <a:tailEnd type="triangle"/>
           </a:ln>
         </p:spPr>
+        <p:txBody>
+          <a:bodyPr/>
+          <a:p/>
+        </p:txBody>
       </p:sp>
       <p:sp>
         <p:nvSpPr>
@@ -7300,6 +7384,10 @@
             <a:prstDash val="solid"/>
           </a:ln>
         </p:spPr>
+        <p:txBody>
+          <a:bodyPr/>
+          <a:p/>
+        </p:txBody>
       </p:sp>
       <p:sp>
         <p:nvSpPr>
@@ -7380,6 +7468,10 @@
             <a:tailEnd type="triangle"/>
           </a:ln>
         </p:spPr>
+        <p:txBody>
+          <a:bodyPr/>
+          <a:p/>
+        </p:txBody>
       </p:sp>
       <p:sp>
         <p:nvSpPr>
@@ -7407,6 +7499,10 @@
             <a:prstDash val="solid"/>
           </a:ln>
         </p:spPr>
+        <p:txBody>
+          <a:bodyPr/>
+          <a:p/>
+        </p:txBody>
       </p:sp>
       <p:sp>
         <p:nvSpPr>
@@ -7487,6 +7583,10 @@
             <a:tailEnd type="triangle"/>
           </a:ln>
         </p:spPr>
+        <p:txBody>
+          <a:bodyPr/>
+          <a:p/>
+        </p:txBody>
       </p:sp>
       <p:sp>
         <p:nvSpPr>
@@ -7514,6 +7614,10 @@
             <a:prstDash val="solid"/>
           </a:ln>
         </p:spPr>
+        <p:txBody>
+          <a:bodyPr/>
+          <a:p/>
+        </p:txBody>
       </p:sp>
       <p:sp>
         <p:nvSpPr>
@@ -7597,6 +7701,10 @@
             <a:prstDash val="solid"/>
           </a:ln>
         </p:spPr>
+        <p:txBody>
+          <a:bodyPr/>
+          <a:p/>
+        </p:txBody>
       </p:sp>
       <p:sp>
         <p:nvSpPr>
@@ -7716,6 +7824,10 @@
             <a:prstDash val="solid"/>
           </a:ln>
         </p:spPr>
+        <p:txBody>
+          <a:bodyPr/>
+          <a:p/>
+        </p:txBody>
       </p:sp>
       <p:sp>
         <p:nvSpPr>
@@ -7835,6 +7947,10 @@
             <a:prstDash val="solid"/>
           </a:ln>
         </p:spPr>
+        <p:txBody>
+          <a:bodyPr/>
+          <a:p/>
+        </p:txBody>
       </p:sp>
       <p:sp>
         <p:nvSpPr>
@@ -7954,6 +8070,10 @@
             <a:prstDash val="solid"/>
           </a:ln>
         </p:spPr>
+        <p:txBody>
+          <a:bodyPr/>
+          <a:p/>
+        </p:txBody>
       </p:sp>
       <p:sp>
         <p:nvSpPr>
@@ -8073,6 +8193,10 @@
             <a:prstDash val="solid"/>
           </a:ln>
         </p:spPr>
+        <p:txBody>
+          <a:bodyPr/>
+          <a:p/>
+        </p:txBody>
       </p:sp>
       <p:sp>
         <p:nvSpPr>
@@ -8192,6 +8316,10 @@
             <a:prstDash val="solid"/>
           </a:ln>
         </p:spPr>
+        <p:txBody>
+          <a:bodyPr/>
+          <a:p/>
+        </p:txBody>
       </p:sp>
       <p:sp>
         <p:nvSpPr>
@@ -8311,6 +8439,10 @@
             <a:prstDash val="solid"/>
           </a:ln>
         </p:spPr>
+        <p:txBody>
+          <a:bodyPr/>
+          <a:p/>
+        </p:txBody>
       </p:sp>
       <p:sp>
         <p:nvSpPr>
@@ -8618,6 +8750,10 @@
             <a:prstDash val="solid"/>
           </a:ln>
         </p:spPr>
+        <p:txBody>
+          <a:bodyPr/>
+          <a:p/>
+        </p:txBody>
       </p:sp>
       <p:sp>
         <p:nvSpPr>
@@ -8740,6 +8876,10 @@
             <a:prstDash val="solid"/>
           </a:ln>
         </p:spPr>
+        <p:txBody>
+          <a:bodyPr/>
+          <a:p/>
+        </p:txBody>
       </p:sp>
       <p:sp>
         <p:nvSpPr>
@@ -8877,7 +9017,7 @@
       </p:sp>
       <p:pic>
         <p:nvPicPr>
-          <p:cNvPr id="11" name="Image 0" descr="C:/Users/User/CoworkProjects/_wrt-shots/deck-out/waitlist-live.png">    </p:cNvPr>
+          <p:cNvPr id="11" name="Image 0" descr="">    </p:cNvPr>
           <p:cNvPicPr>
             <a:picLocks noChangeAspect="1"/>
           </p:cNvPicPr>
@@ -8927,6 +9067,10 @@
             <a:prstDash val="solid"/>
           </a:ln>
         </p:spPr>
+        <p:txBody>
+          <a:bodyPr/>
+          <a:p/>
+        </p:txBody>
       </p:sp>
       <p:sp>
         <p:nvSpPr>
@@ -8969,7 +9113,7 @@
       </p:sp>
       <p:pic>
         <p:nvPicPr>
-          <p:cNvPr id="14" name="Image 1" descr="C:/Users/User/CoworkProjects/_wrt-shots/deck-out/neon-tables-crop.png">    </p:cNvPr>
+          <p:cNvPr id="14" name="Image 1" descr="">    </p:cNvPr>
           <p:cNvPicPr>
             <a:picLocks noChangeAspect="1"/>
           </p:cNvPicPr>
@@ -9019,6 +9163,10 @@
             <a:prstDash val="solid"/>
           </a:ln>
         </p:spPr>
+        <p:txBody>
+          <a:bodyPr/>
+          <a:p/>
+        </p:txBody>
       </p:sp>
       <p:sp>
         <p:nvSpPr>
@@ -9507,6 +9655,10 @@
             <a:prstDash val="solid"/>
           </a:ln>
         </p:spPr>
+        <p:txBody>
+          <a:bodyPr/>
+          <a:p/>
+        </p:txBody>
       </p:sp>
       <p:sp>
         <p:nvSpPr>
@@ -9676,6 +9828,10 @@
             <a:prstDash val="solid"/>
           </a:ln>
         </p:spPr>
+        <p:txBody>
+          <a:bodyPr/>
+          <a:p/>
+        </p:txBody>
       </p:sp>
       <p:sp>
         <p:nvSpPr>
@@ -10391,7 +10547,7 @@
       </p:sp>
       <p:pic>
         <p:nvPicPr>
-          <p:cNvPr id="17" name="Image 0" descr="C:/Users/User/CoworkProjects/_wrt-shots/deck-out/title-screen-prod.png">    </p:cNvPr>
+          <p:cNvPr id="17" name="Image 0" descr="">    </p:cNvPr>
           <p:cNvPicPr>
             <a:picLocks noChangeAspect="1"/>
           </p:cNvPicPr>
@@ -10441,6 +10597,10 @@
             <a:prstDash val="solid"/>
           </a:ln>
         </p:spPr>
+        <p:txBody>
+          <a:bodyPr/>
+          <a:p/>
+        </p:txBody>
       </p:sp>
       <p:sp>
         <p:nvSpPr>
@@ -10468,6 +10628,10 @@
             <a:prstDash val="solid"/>
           </a:ln>
         </p:spPr>
+        <p:txBody>
+          <a:bodyPr/>
+          <a:p/>
+        </p:txBody>
       </p:sp>
       <p:sp>
         <p:nvSpPr>

</xml_diff>

<commit_message>
Drop the database screenshot from the class deck
Slide 7 of the June presentation embedded a console screenshot of the
retired signup table with stored rows; the picture is removed and its
caption says so. The DOM smoke test's privacy checks now print their
detail only on failure.

Co-Authored-By: Claude Fable 5.1 <noreply@anthropic.com>
Claude-Session: https://claude.ai/code/session_0187QpzSj3Q4KUbxmFcYfboj
</commit_message>
<xml_diff>
--- a/submission-media/ENGR5513-FinalBoss-Presentation.pptx
+++ b/submission-media/ENGR5513-FinalBoss-Presentation.pptx
@@ -9111,30 +9111,6 @@
           </a:p>
         </p:txBody>
       </p:sp>
-      <p:pic>
-        <p:nvPicPr>
-          <p:cNvPr id="14" name="Image 1" descr="">    </p:cNvPr>
-          <p:cNvPicPr>
-            <a:picLocks noChangeAspect="1"/>
-          </p:cNvPicPr>
-          <p:nvPr/>
-        </p:nvPicPr>
-        <p:blipFill>
-          <a:blip r:embed="rId2"/>
-          <a:stretch>
-            <a:fillRect/>
-          </a:stretch>
-        </p:blipFill>
-        <p:spPr>
-          <a:xfrm>
-            <a:off x="5257800" y="3767328"/>
-            <a:ext cx="3429000" cy="914400"/>
-          </a:xfrm>
-          <a:prstGeom prst="rect">
-            <a:avLst/>
-          </a:prstGeom>
-        </p:spPr>
-      </p:pic>
       <p:sp>
         <p:nvSpPr>
           <p:cNvPr id="15" name="Shape 11"/>
@@ -9201,7 +9177,7 @@
                 <a:ea typeface="Consolas" pitchFamily="34" charset="-122"/>
                 <a:cs typeface="Consolas" pitchFamily="34" charset="-120"/>
               </a:rPr>
-              <a:t>Neon console — email_signups rows, all three tables</a:t>
+              <a:t>Neon console screenshot omitted from the public copy (it showed stored signup rows)</a:t>
             </a:r>
             <a:endParaRPr lang="en-US" sz="800" dirty="0"/>
           </a:p>

</xml_diff>